<commit_message>
Prezentacja v6: Stefan & Oskar na okładce, slajd końcowy
Co-Authored-By: Claude Sonnet 5.5 <noreply@anthropic.com>
Claude-Session: https://claude.ai/code/session_01RxET8S5NWKo13oo2mh7L1U
</commit_message>
<xml_diff>
--- a/projekty/warsztaty-beauty-product/swiatlo-jako-narzedzie-pracy-v6.pptx
+++ b/projekty/warsztaty-beauty-product/swiatlo-jako-narzedzie-pracy-v6.pptx
@@ -37,6 +37,7 @@
     <p:sldId id="278" r:id="rId27"/>
     <p:sldId id="279" r:id="rId28"/>
     <p:sldId id="280" r:id="rId29"/>
+    <p:sldId id="284" r:id="rId42"/>
   </p:sldIdLst>
   <p:sldSz cx="12192000" cy="6858000"/>
   <p:notesSz cx="6858000" cy="9144000"/>
@@ -17406,7 +17407,7 @@
                 <a:ea typeface="Calibri"/>
                 <a:cs typeface="Calibri"/>
               </a:rPr>
-              <a:t>Stefan Kawka &amp; Oskar</a:t>
+              <a:t>Stefan &amp; Oskar</a:t>
             </a:r>
           </a:p>
         </p:txBody>
@@ -28622,6 +28623,113 @@
     <p:extLst>
       <p:ext uri="{BB962C8B-B14F-4D97-AF65-F5344CB8AC3E}">
         <p14:creationId xmlns:p14="http://schemas.microsoft.com/office/powerpoint/2010/main" val="3798427714"/>
+      </p:ext>
+    </p:extLst>
+  </p:cSld>
+  <p:clrMapOvr>
+    <a:masterClrMapping/>
+  </p:clrMapOvr>
+</p:sld>
+</file>
+
+<file path=ppt/slides/slide29.xml><?xml version="1.0" encoding="utf-8"?>
+<p:sld xmlns:a="http://schemas.openxmlformats.org/drawingml/2006/main" xmlns:r="http://schemas.openxmlformats.org/officeDocument/2006/relationships" xmlns:p="http://schemas.openxmlformats.org/presentationml/2006/main">
+  <p:cSld>
+    <p:spTree>
+      <p:nvGrpSpPr>
+        <p:cNvPr id="1" name=""/>
+        <p:cNvGrpSpPr/>
+        <p:nvPr/>
+      </p:nvGrpSpPr>
+      <p:grpSpPr>
+        <a:xfrm>
+          <a:off x="0" y="0"/>
+          <a:ext cx="0" cy="0"/>
+          <a:chOff x="0" y="0"/>
+          <a:chExt cx="0" cy="0"/>
+        </a:xfrm>
+      </p:grpSpPr>
+      <p:sp>
+        <p:nvSpPr>
+          <p:cNvPr id="2" name="Tytuł 1">
+            <a:extLst>
+              <a:ext uri="{FF2B5EF4-FFF2-40B4-BE49-F238E27FC236}">
+                <a16:creationId xmlns:a16="http://schemas.microsoft.com/office/drawing/2014/main" id="{216815C6-3AD0-46E6-A74A-1967BD91AF50}"/>
+              </a:ext>
+            </a:extLst>
+          </p:cNvPr>
+          <p:cNvSpPr>
+            <a:spLocks noGrp="1"/>
+          </p:cNvSpPr>
+          <p:nvPr>
+            <p:ph type="ctrTitle"/>
+          </p:nvPr>
+        </p:nvSpPr>
+        <p:spPr>
+          <a:xfrm>
+            <a:off x="6416040" y="4434840"/>
+            <a:ext cx="4941771" cy="1122202"/>
+          </a:xfrm>
+        </p:spPr>
+        <p:txBody>
+          <a:bodyPr rtlCol="0"/>
+          <a:lstStyle/>
+          <a:p>
+            <a:r>
+              <a:rPr lang="pl-PL">
+                <a:latin typeface="Calibri"/>
+                <a:ea typeface="Calibri"/>
+                <a:cs typeface="Calibri"/>
+              </a:rPr>
+              <a:t>Dziękujemy za uwagę</a:t>
+            </a:r>
+            <a:endParaRPr lang="pl-PL"/>
+          </a:p>
+        </p:txBody>
+      </p:sp>
+      <p:sp>
+        <p:nvSpPr>
+          <p:cNvPr id="3" name="Podtytuł 2">
+            <a:extLst>
+              <a:ext uri="{FF2B5EF4-FFF2-40B4-BE49-F238E27FC236}">
+                <a16:creationId xmlns:a16="http://schemas.microsoft.com/office/drawing/2014/main" id="{1901B20D-4C28-4DA3-ABBD-718C22A5E58B}"/>
+              </a:ext>
+            </a:extLst>
+          </p:cNvPr>
+          <p:cNvSpPr>
+            <a:spLocks noGrp="1"/>
+          </p:cNvSpPr>
+          <p:nvPr>
+            <p:ph type="subTitle" idx="1"/>
+          </p:nvPr>
+        </p:nvSpPr>
+        <p:spPr>
+          <a:xfrm>
+            <a:off x="6416041" y="5586890"/>
+            <a:ext cx="4941770" cy="396660"/>
+          </a:xfrm>
+        </p:spPr>
+        <p:txBody>
+          <a:bodyPr vert="horz" lIns="91440" tIns="45720" rIns="91440" bIns="45720" rtlCol="0" anchor="t">
+            <a:normAutofit/>
+          </a:bodyPr>
+          <a:lstStyle/>
+          <a:p>
+            <a:r>
+              <a:rPr lang="pl-PL">
+                <a:latin typeface="Calibri"/>
+                <a:ea typeface="Calibri"/>
+                <a:cs typeface="Calibri"/>
+              </a:rPr>
+              <a:t>Stefan &amp; Oskar</a:t>
+            </a:r>
+          </a:p>
+        </p:txBody>
+      </p:sp>
+    </p:spTree>
+    <p:extLst>
+      <p:ext uri="{BB962C8B-B14F-4D97-AF65-F5344CB8AC3E}">
+        <p14:creationId xmlns:p14="http://schemas.microsoft.com/office/powerpoint/2010/main" val="1642425379"/>
       </p:ext>
     </p:extLst>
   </p:cSld>

</xml_diff>